<commit_message>
Lead the overview with the model layer
The deck enters the model-agent section right after this page, so the
column the audience reads first should be the one they are about to see
in detail. Swapping the columns also turns the exchange into an
out-and-back: the bottleneck travels right to xpugen, the verified
kernel comes back left into phase C.
</commit_message>
<xml_diff>
--- a/slides/agents_overview.pptx
+++ b/slides/agents_overview.pptx
@@ -551,7 +551,7 @@
                 <a:ea typeface="Microsoft YaHei"/>
                 <a:cs typeface="Microsoft YaHei"/>
               </a:rPr>
-              <a:t>左边 xpugen 工作在算子层，给国产 GPU 写内核，产出的是 M100 原生的 .xpu，不是 CUDA。右边 m100-model-agent 工作在模型层，在 SGLang 上完成模型适配，再提升实测性能。</a:t>
+              <a:t>左边 m100-model-agent 工作在模型层，在 SGLang 上完成模型适配，再提升实测性能。右边 xpugen 工作在算子层，给国产 GPU 写内核，产出的是 M100 原生的 .xpu，不是 CUDA。</a:t>
             </a:r>
           </a:p>
           <a:p>
@@ -569,7 +569,7 @@
                 <a:ea typeface="Microsoft YaHei"/>
                 <a:cs typeface="Microsoft YaHei"/>
               </a:rPr>
-              <a:t>两者的结构是一样的，每一列中间的三个方块就是各自的判定链：模型只负责提出方案，是否合格由固定规则与真机实测决定，不由模型自己解释。两边还各有一个不作判据的诊断步骤——xpugen 用模拟器定位瓶颈，model-agent 用独立进程采集 trace，它们的数据都不计入收益。</a:t>
+              <a:t>两者的结构是一样的，每一列中间的三个方块就是各自的判定链，写的都是通过条件：模型只负责提出方案，是否合格由固定规则与真机实测决定，不由模型自己解释。两边还各有一个不作判据的诊断步骤——model-agent 用独立进程采集 trace，xpugen 用模拟器定位瓶颈，它们的数据都不计入收益。</a:t>
             </a:r>
           </a:p>
           <a:p>
@@ -587,7 +587,7 @@
                 <a:ea typeface="Microsoft YaHei"/>
                 <a:cs typeface="Microsoft YaHei"/>
               </a:rPr>
-              <a:t>真正的区别是加了底色的那一行，测量范围。xpugen 测的是单算子，在 bench harness 上对照 CPU 参考；model-agent 测的是整模型，真实服务、全量评测。</a:t>
+              <a:t>真正的区别是加了底色的那一行，测量范围。model-agent 测的是整模型，真实服务、全量评测；xpugen 测的是单算子，在 bench harness 上对照 CPU 参考。</a:t>
             </a:r>
           </a:p>
           <a:p>
@@ -605,7 +605,7 @@
                 <a:ea typeface="Microsoft YaHei"/>
                 <a:cs typeface="Microsoft YaHei"/>
               </a:rPr>
-              <a:t>中间两条箭头是协作关系。向左这条：model-agent 在 B 阶段定位到的瓶颈算子，转为 xpugen 的内核需求。向右这条：xpugen 验证通过的内核，作为候选补丁进入 model-agent 的 C 阶段。</a:t>
+              <a:t>中间两条箭头是协作关系。向右这条：model-agent 在 B 阶段定位到的瓶颈算子，转为 xpugen 的内核需求。向左这条：xpugen 验证通过的内核，回到 model-agent 的 C 阶段，作为候选补丁重新判定。</a:t>
             </a:r>
           </a:p>
           <a:p>
@@ -623,7 +623,7 @@
                 <a:ea typeface="Microsoft YaHei"/>
                 <a:cs typeface="Microsoft YaHei"/>
               </a:rPr>
-              <a:t>这里有一个容易被忽略的点，也就是最下面这句话：单算子提速不等于整模型提速。bench 只证明这个算子本身更快，它可能并不在关键路径上，也可能带来额外的访存开销。所以同一个内核要在两层各判定一次，只有通过模型层性能门的部分才计入交付。</a:t>
+              <a:t>这里有一个容易被忽略的点，也就是最下面这句话：单算子提速不等于整模型提速。bench 只证明这个算子本身更快，它可能并不在关键路径上，也可能带来额外的访存开销。所以同一个内核要在两层各判定一次，只有在模型层也确实更快的部分才计入交付。</a:t>
             </a:r>
           </a:p>
           <a:p>
@@ -3743,7 +3743,7 @@
                 <a:ea typeface="Microsoft YaHei"/>
                 <a:cs typeface="Microsoft YaHei"/>
               </a:rPr>
-              <a:t>AGENT 纵览 · 算子层与模型层</a:t>
+              <a:t>AGENT 纵览 · 模型层与算子层</a:t>
             </a:r>
           </a:p>
         </p:txBody>
@@ -3790,7 +3790,7 @@
                 <a:ea typeface="Microsoft YaHei"/>
                 <a:cs typeface="Microsoft YaHei"/>
               </a:rPr>
-              <a:t>两个 Agent：xpugen 写算子，m100-model-agent 调模型</a:t>
+              <a:t>两个 Agent：m100-model-agent 调模型，xpugen 写算子</a:t>
             </a:r>
           </a:p>
         </p:txBody>
@@ -3942,7 +3942,7 @@
                 <a:ea typeface="Microsoft YaHei"/>
                 <a:cs typeface="Microsoft YaHei"/>
               </a:rPr>
-              <a:t>xpugen</a:t>
+              <a:t>m100-model-agent</a:t>
             </a:r>
             <a:r>
               <a:rPr sz="1200" b="0">
@@ -3953,7 +3953,7 @@
                 <a:ea typeface="Microsoft YaHei"/>
                 <a:cs typeface="Microsoft YaHei"/>
               </a:rPr>
-              <a:t>　算子层</a:t>
+              <a:t>　模型层</a:t>
             </a:r>
           </a:p>
         </p:txBody>
@@ -4000,7 +4000,7 @@
                 <a:ea typeface="Microsoft YaHei"/>
                 <a:cs typeface="Microsoft YaHei"/>
               </a:rPr>
-              <a:t>给国产 GPU 写算子，产出 M100 原生内核（.xpu）</a:t>
+              <a:t>在 SGLang 上完成模型适配，并提升实测性能</a:t>
             </a:r>
           </a:p>
         </p:txBody>
@@ -4124,7 +4124,7 @@
                 <a:ea typeface="Microsoft YaHei"/>
                 <a:cs typeface="Microsoft YaHei"/>
               </a:rPr>
-              <a:t>L0 编译运行</a:t>
+              <a:t>① 输出未变</a:t>
             </a:r>
           </a:p>
         </p:txBody>
@@ -4180,7 +4180,7 @@
                 <a:ea typeface="Microsoft YaHei"/>
                 <a:cs typeface="Microsoft YaHei"/>
               </a:rPr>
-              <a:t>L1 数值正确</a:t>
+              <a:t>② 质量未降</a:t>
             </a:r>
           </a:p>
         </p:txBody>
@@ -4258,7 +4258,7 @@
                 <a:ea typeface="Microsoft YaHei"/>
                 <a:cs typeface="Microsoft YaHei"/>
               </a:rPr>
-              <a:t>bench 真机提速</a:t>
+              <a:t>③ 确实更快</a:t>
             </a:r>
           </a:p>
         </p:txBody>
@@ -4327,7 +4327,7 @@
                 <a:ea typeface="Microsoft YaHei"/>
                 <a:cs typeface="Microsoft YaHei"/>
               </a:rPr>
-              <a:t>profile 用模拟器定位瓶颈，不作判据</a:t>
+              <a:t>profiling 独立进程采 trace，不计入收益</a:t>
             </a:r>
           </a:p>
         </p:txBody>
@@ -4450,7 +4450,7 @@
                 <a:ea typeface="Microsoft YaHei"/>
                 <a:cs typeface="Microsoft YaHei"/>
               </a:rPr>
-              <a:t>单算子，bench harness，对照 CPU 参考实现</a:t>
+              <a:t>整模型，真实服务，120 题全量评测</a:t>
             </a:r>
           </a:p>
         </p:txBody>
@@ -4575,7 +4575,7 @@
                 <a:ea typeface="Microsoft YaHei"/>
                 <a:cs typeface="Microsoft YaHei"/>
               </a:rPr>
-              <a:t>精度默认 8 轮；性能 50 轮无进展才判停滞</a:t>
+              <a:t>最多 6 轮候选，总预算 36000 秒</a:t>
             </a:r>
           </a:p>
         </p:txBody>
@@ -4680,7 +4680,7 @@
                 <a:ea typeface="Microsoft YaHei"/>
                 <a:cs typeface="Microsoft YaHei"/>
               </a:rPr>
-              <a:t>m100-model-agent</a:t>
+              <a:t>xpugen</a:t>
             </a:r>
             <a:r>
               <a:rPr sz="1200" b="0">
@@ -4691,7 +4691,7 @@
                 <a:ea typeface="Microsoft YaHei"/>
                 <a:cs typeface="Microsoft YaHei"/>
               </a:rPr>
-              <a:t>　模型层</a:t>
+              <a:t>　算子层</a:t>
             </a:r>
           </a:p>
         </p:txBody>
@@ -4738,7 +4738,7 @@
                 <a:ea typeface="Microsoft YaHei"/>
                 <a:cs typeface="Microsoft YaHei"/>
               </a:rPr>
-              <a:t>在 SGLang 上完成模型适配，并提升实测性能</a:t>
+              <a:t>给国产 GPU 写算子，产出 M100 原生内核（.xpu）</a:t>
             </a:r>
           </a:p>
         </p:txBody>
@@ -4862,7 +4862,7 @@
                 <a:ea typeface="Microsoft YaHei"/>
                 <a:cs typeface="Microsoft YaHei"/>
               </a:rPr>
-              <a:t>① 数值门</a:t>
+              <a:t>L0 能编译运行</a:t>
             </a:r>
           </a:p>
         </p:txBody>
@@ -4918,7 +4918,7 @@
                 <a:ea typeface="Microsoft YaHei"/>
                 <a:cs typeface="Microsoft YaHei"/>
               </a:rPr>
-              <a:t>② 质量门</a:t>
+              <a:t>L1 数值正确</a:t>
             </a:r>
           </a:p>
         </p:txBody>
@@ -4996,7 +4996,7 @@
                 <a:ea typeface="Microsoft YaHei"/>
                 <a:cs typeface="Microsoft YaHei"/>
               </a:rPr>
-              <a:t>③ 性能门</a:t>
+              <a:t>bench 真机更快</a:t>
             </a:r>
           </a:p>
         </p:txBody>
@@ -5065,7 +5065,7 @@
                 <a:ea typeface="Microsoft YaHei"/>
                 <a:cs typeface="Microsoft YaHei"/>
               </a:rPr>
-              <a:t>profiling 独立进程采 trace，不计入收益</a:t>
+              <a:t>profile 用模拟器定位瓶颈，不作判据</a:t>
             </a:r>
           </a:p>
         </p:txBody>
@@ -5188,7 +5188,7 @@
                 <a:ea typeface="Microsoft YaHei"/>
                 <a:cs typeface="Microsoft YaHei"/>
               </a:rPr>
-              <a:t>整模型，真实服务，120 题全量评测</a:t>
+              <a:t>单算子，bench harness，对照 CPU 参考实现</a:t>
             </a:r>
           </a:p>
         </p:txBody>
@@ -5313,7 +5313,7 @@
                 <a:ea typeface="Microsoft YaHei"/>
                 <a:cs typeface="Microsoft YaHei"/>
               </a:rPr>
-              <a:t>最多 6 轮候选，总预算 36000 秒</a:t>
+              <a:t>精度默认 8 轮；性能 50 轮无进展才判停滞</a:t>
             </a:r>
           </a:p>
         </p:txBody>
@@ -5372,7 +5372,7 @@
           <p:nvPr/>
         </p:nvCxnSpPr>
         <p:spPr>
-          <a:xfrm flipH="1">
+          <a:xfrm>
             <a:off x="4901183" y="2788920"/>
             <a:ext cx="2389328" cy="0"/>
           </a:xfrm>
@@ -5488,7 +5488,7 @@
           <p:nvPr/>
         </p:nvCxnSpPr>
         <p:spPr>
-          <a:xfrm>
+          <a:xfrm flipH="1">
             <a:off x="4901183" y="4197096"/>
             <a:ext cx="2389328" cy="0"/>
           </a:xfrm>
@@ -5545,7 +5545,7 @@
                 <a:ea typeface="Microsoft YaHei"/>
                 <a:cs typeface="Microsoft YaHei"/>
               </a:rPr>
-              <a:t>进入 C 阶段，重新判定一次</a:t>
+              <a:t>回到 C 阶段，重新判定一次</a:t>
             </a:r>
           </a:p>
         </p:txBody>
@@ -5708,7 +5708,7 @@
                 <a:ea typeface="Microsoft YaHei"/>
                 <a:cs typeface="Microsoft YaHei"/>
               </a:rPr>
-              <a:t>xpugen 的 bench 证明算子本身更快，m100-model-agent 的性能门证明整模型更快；只有后者计入交付</a:t>
+              <a:t>xpugen 的 bench 只证明算子本身更快；能否计入交付，取决于 m100-model-agent 的第三道判定</a:t>
             </a:r>
           </a:p>
         </p:txBody>

</xml_diff>